<commit_message>
Point the talk at live.floati.life for good
The address is now a name we own, so it survives restarts and the QR on the
slide stays correct. nginx on the floati box terminates TLS and forwards to
a port that an ssh reverse tunnel puts on the docker bridge.

The event stream survives this proxy, which it did not survive on Cloudflare:
five events, first at about a second, against zero before. That is the
proxy_buffering off in our own config doing the work.

Deck rebuilt against the new name and the codes decoded back out of the file
to check them, rather than trusting the build.

Co-Authored-By: Claude Opus 4.8 <noreply@anthropic.com>
</commit_message>
<xml_diff>
--- a/slides/One-Prompt-Many-Workers-Light.pptx
+++ b/slides/One-Prompt-Many-Workers-Light.pptx
@@ -21647,7 +21647,7 @@
               <a:buNone/>
             </a:pPr>
             <a:r>
-              <a:rPr lang="en-US" sz="850" dirty="0">
+              <a:rPr lang="en-US" sz="1000" dirty="0">
                 <a:solidFill>
                   <a:srgbClr val="4F46E5"/>
                 </a:solidFill>
@@ -21655,9 +21655,9 @@
                 <a:ea typeface="Consolas" pitchFamily="34" charset="-122"/>
                 <a:cs typeface="Consolas" pitchFamily="34" charset="-120"/>
               </a:rPr>
-              <a:t>makers-farming-rpg-alert.trycloudflare.com</a:t>
-            </a:r>
-            <a:endParaRPr lang="en-US" sz="850" dirty="0"/>
+              <a:t>live.floati.life</a:t>
+            </a:r>
+            <a:endParaRPr lang="en-US" sz="1000" dirty="0"/>
           </a:p>
         </p:txBody>
       </p:sp>

</xml_diff>

<commit_message>
Stop promising the room something that is no longer true
The audience page told everyone that nothing they typed left the building,
and the stage said every token was on this laptop. Both were written when
the model was on the laptop. Running a hosted model, and reaching the room
through a tunnel, neither is true, and someone at a dev talk will ask.

The app knows which it is, so it says so. info now reports whether the model
is local, and the join page, the stage banner and the footer all read from
that. On the local model the original promise comes back word for word. On a
hosted model the page says plainly that the writing is done elsewhere, so
your line does leave the building.

The title slide no longer claims no cloud, and the where it runs slide notes
to say aloud which you are running.

Checked both ways: local gemma reports local, GLM reports hosted, and each
page renders the matching line.

Co-Authored-By: Claude Opus 4.8 <noreply@anthropic.com>
</commit_message>
<xml_diff>
--- a/slides/One-Prompt-Many-Workers-Light.pptx
+++ b/slides/One-Prompt-Many-Workers-Light.pptx
@@ -978,7 +978,7 @@
           <a:p>
             <a:r>
               <a:rPr lang="en-US" dirty="0"/>
-              <a:t>The model runs entirely on this laptop. The client's data never leaves the building. No token bill that scales with success. Works on a plane. For a bank, it never leaves the building is the whole conversation.</a:t>
+              <a:t>Say which one you are running tonight before this slide. On the local model every token stays here. On a hosted model the crew still runs here and only the writing goes out. The point is that the harness does not care.  Original: The model runs entirely on this laptop. The client's data never leaves the building. No token bill that scales with success. Works on a plane. For a bank, it never leaves the building is the whole conversation.</a:t>
             </a:r>
             <a:endParaRPr lang="en-US" dirty="0"/>
           </a:p>
@@ -4318,7 +4318,7 @@
                 <a:ea typeface="Consolas" pitchFamily="34" charset="-122"/>
                 <a:cs typeface="Consolas" pitchFamily="34" charset="-120"/>
               </a:rPr>
-              <a:t>local model   ·   no cloud   ·   live code</a:t>
+              <a:t>real agents   ·   real code   ·   built live in the room</a:t>
             </a:r>
             <a:endParaRPr lang="en-US" sz="1250" dirty="0"/>
           </a:p>

</xml_diff>

<commit_message>
Put the real code on the code slides
The two live code slides showed a tidied up sketch that does not appear
anywhere in the project: a Worker interface with a role parameter, and a for
loop over a Plan. Nice on a slide, but if anyone opens the repo afterwards
it is not there, and a talk that says look how little code this takes should
show the code it actually takes.

Both slides are now lifted out of the source. Slide one is the Namer
interface from Agents.java, kept as written, prompt included, because most
of that prompt being a list of things not to do is the honest part. Slide
two is the four pool.submit lines from runCrew, which is the many workers
claim in actual code. The record slide gained the badge field it really has.

Co-Authored-By: Claude Opus 4.8 <noreply@anthropic.com>
</commit_message>
<xml_diff>
--- a/slides/One-Prompt-Many-Workers-Light.pptx
+++ b/slides/One-Prompt-Many-Workers-Light.pptx
@@ -2122,7 +2122,7 @@
           <a:p>
             <a:r>
               <a:rPr lang="en-US" dirty="0"/>
-              <a:t>A worker in LangChain4j is an interface. No implementation. The annotations are the program. The system message makes it a specialist, role and task get slotted in. One interface backs every worker, that is the many workers line in code.</a:t>
+              <a:t>This is the real file, not a tidied up version. A worker is a Java interface and nothing else. I never wrote an implementation. The annotations are the program: the system message is the whole personality, and look at it, most of that prompt is me telling it what NOT to do. Never end in ly or Hub. That is a rule I added because the model kept handing me Choreify. The examples at the bottom are doing the real work.</a:t>
             </a:r>
             <a:endParaRPr lang="en-US" dirty="0"/>
           </a:p>
@@ -2210,7 +2210,7 @@
           <a:p>
             <a:r>
               <a:rPr lang="en-US" dirty="0"/>
-              <a:t>The orchestrator is the whole talk in fifteen lines. The planner turns one prompt into a crew, a typed Plan. We loop, each worker does its job, we collect notes, the synthesizer folds them into one answer. Fan out, fan in. Now, let's run it.</a:t>
+              <a:t>And this is the many workers bit, also verbatim. Four pool.submit calls, four agents running at the same time, each one line. No framework, just a Java executor. The namer finishes first because it has the smallest job, and the moment it does, three other agents unblock. That is the web you saw on the slide, in actual code. Now let us run it.</a:t>
             </a:r>
             <a:endParaRPr lang="en-US" dirty="0"/>
           </a:p>
@@ -18293,7 +18293,7 @@
                 <a:ea typeface="Consolas" pitchFamily="34" charset="-122"/>
                 <a:cs typeface="Consolas" pitchFamily="34" charset="-120"/>
               </a:rPr>
-              <a:t>// the Copywriter's return type
+              <a:t>// Model.java, verbatim
 </a:t>
             </a:r>
             <a:pPr indent="0" marL="0">
@@ -18346,6 +18346,41 @@
                 <a:cs typeface="Consolas" pitchFamily="34" charset="-120"/>
               </a:rPr>
               <a:t>(
+</a:t>
+            </a:r>
+            <a:pPr indent="0" marL="0">
+              <a:lnSpc>
+                <a:spcPts val="2500"/>
+              </a:lnSpc>
+              <a:buNone/>
+            </a:pPr>
+            <a:r>
+              <a:rPr lang="en-US" sz="1400" dirty="0">
+                <a:solidFill>
+                  <a:srgbClr val="7DD3FC"/>
+                </a:solidFill>
+                <a:latin typeface="Consolas" pitchFamily="34" charset="0"/>
+                <a:ea typeface="Consolas" pitchFamily="34" charset="-122"/>
+                <a:cs typeface="Consolas" pitchFamily="34" charset="-120"/>
+              </a:rPr>
+              <a:t>   String </a:t>
+            </a:r>
+            <a:pPr indent="0" marL="0">
+              <a:lnSpc>
+                <a:spcPts val="2500"/>
+              </a:lnSpc>
+              <a:buNone/>
+            </a:pPr>
+            <a:r>
+              <a:rPr lang="en-US" sz="1400" dirty="0">
+                <a:solidFill>
+                  <a:srgbClr val="E6E9F0"/>
+                </a:solidFill>
+                <a:latin typeface="Consolas" pitchFamily="34" charset="0"/>
+                <a:ea typeface="Consolas" pitchFamily="34" charset="-122"/>
+                <a:cs typeface="Consolas" pitchFamily="34" charset="-120"/>
+              </a:rPr>
+              <a:t>badge,
 </a:t>
             </a:r>
             <a:pPr indent="0" marL="0">
@@ -18847,7 +18882,7 @@
                 <a:ea typeface="Arial" pitchFamily="34" charset="-122"/>
                 <a:cs typeface="Arial" pitchFamily="34" charset="-120"/>
               </a:rPr>
-              <a:t>LIVE CODE  /  1 OF 2</a:t>
+              <a:t>LIVE CODE  /  1 OF 2  ·  AGENTS.JAVA</a:t>
             </a:r>
             <a:endParaRPr lang="en-US" sz="1100" dirty="0"/>
           </a:p>
@@ -18886,7 +18921,7 @@
                 <a:ea typeface="Arial" pitchFamily="34" charset="-122"/>
                 <a:cs typeface="Arial" pitchFamily="34" charset="-120"/>
               </a:rPr>
-              <a:t>One interface. </a:t>
+              <a:t>A worker is an </a:t>
             </a:r>
             <a:pPr indent="0" marL="0">
               <a:buNone/>
@@ -18900,7 +18935,7 @@
                 <a:ea typeface="Arial" pitchFamily="34" charset="-122"/>
                 <a:cs typeface="Arial" pitchFamily="34" charset="-120"/>
               </a:rPr>
-              <a:t>Every worker.</a:t>
+              <a:t>interface.</a:t>
             </a:r>
             <a:endParaRPr lang="en-US" sz="2700" dirty="0"/>
           </a:p>
@@ -18976,7 +19011,7 @@
                 <a:ea typeface="Consolas" pitchFamily="34" charset="-122"/>
                 <a:cs typeface="Consolas" pitchFamily="34" charset="-120"/>
               </a:rPr>
-              <a:t>// No implementation. The annotations are the program.</a:t>
+              <a:t>// Agents.java, verbatim. There is no implementation anywhere.</a:t>
             </a:r>
             <a:endParaRPr lang="en-US" sz="1550" dirty="0"/>
           </a:p>
@@ -18996,7 +19031,7 @@
                 <a:ea typeface="Consolas" pitchFamily="34" charset="-122"/>
                 <a:cs typeface="Consolas" pitchFamily="34" charset="-120"/>
               </a:rPr>
-              <a:t>interface </a:t>
+              <a:t>public interface </a:t>
             </a:r>
             <a:pPr indent="0" marL="0">
               <a:lnSpc>
@@ -19013,7 +19048,7 @@
                 <a:ea typeface="Consolas" pitchFamily="34" charset="-122"/>
                 <a:cs typeface="Consolas" pitchFamily="34" charset="-120"/>
               </a:rPr>
-              <a:t>Worker</a:t>
+              <a:t>Namer</a:t>
             </a:r>
             <a:pPr indent="0" marL="0">
               <a:lnSpc>
@@ -19041,9 +19076,17 @@
               </a:lnSpc>
               <a:buNone/>
             </a:pPr>
-            <a:endParaRPr lang="en-US" sz="1550" dirty="0"/>
-          </a:p>
-          <a:p>
+            <a:r>
+              <a:rPr lang="en-US" sz="1550" dirty="0">
+                <a:solidFill>
+                  <a:srgbClr val="FBBF24"/>
+                </a:solidFill>
+                <a:latin typeface="Consolas" pitchFamily="34" charset="0"/>
+                <a:ea typeface="Consolas" pitchFamily="34" charset="-122"/>
+                <a:cs typeface="Consolas" pitchFamily="34" charset="-120"/>
+              </a:rPr>
+              <a:t>  @SystemMessage</a:t>
+            </a:r>
             <a:pPr indent="0" marL="0">
               <a:lnSpc>
                 <a:spcPts val="3000"/>
@@ -19053,14 +19096,17 @@
             <a:r>
               <a:rPr lang="en-US" sz="1550" dirty="0">
                 <a:solidFill>
-                  <a:srgbClr val="FBBF24"/>
+                  <a:srgbClr val="E6E9F0"/>
                 </a:solidFill>
                 <a:latin typeface="Consolas" pitchFamily="34" charset="0"/>
                 <a:ea typeface="Consolas" pitchFamily="34" charset="-122"/>
                 <a:cs typeface="Consolas" pitchFamily="34" charset="-120"/>
               </a:rPr>
-              <a:t>  @SystemMessage</a:t>
-            </a:r>
+              <a:t>("""</a:t>
+            </a:r>
+            <a:endParaRPr lang="en-US" sz="1550" dirty="0"/>
+          </a:p>
+          <a:p>
             <a:pPr indent="0" marL="0">
               <a:lnSpc>
                 <a:spcPts val="3000"/>
@@ -19070,14 +19116,17 @@
             <a:r>
               <a:rPr lang="en-US" sz="1550" dirty="0">
                 <a:solidFill>
-                  <a:srgbClr val="E6E9F0"/>
+                  <a:srgbClr val="6EE7D8"/>
                 </a:solidFill>
                 <a:latin typeface="Consolas" pitchFamily="34" charset="0"/>
                 <a:ea typeface="Consolas" pitchFamily="34" charset="-122"/>
                 <a:cs typeface="Consolas" pitchFamily="34" charset="-120"/>
               </a:rPr>
-              <a:t>(</a:t>
-            </a:r>
+              <a:t>      You name products. Given an idea, give ONE name of 4 to 14</a:t>
+            </a:r>
+            <a:endParaRPr lang="en-US" sz="1550" dirty="0"/>
+          </a:p>
+          <a:p>
             <a:pPr indent="0" marL="0">
               <a:lnSpc>
                 <a:spcPts val="3000"/>
@@ -19093,14 +19142,28 @@
                 <a:ea typeface="Consolas" pitchFamily="34" charset="-122"/>
                 <a:cs typeface="Consolas" pitchFamily="34" charset="-120"/>
               </a:rPr>
-              <a:t>"You are a {{role}}.</a:t>
-            </a:r>
+              <a:t>      letters, easy to say out loud, one or two words.</a:t>
+            </a:r>
+            <a:endParaRPr lang="en-US" sz="1550" dirty="0"/>
+          </a:p>
+          <a:p>
             <a:pPr indent="0" marL="0">
               <a:lnSpc>
                 <a:spcPts val="3000"/>
               </a:lnSpc>
               <a:buNone/>
             </a:pPr>
+            <a:r>
+              <a:rPr lang="en-US" sz="1550" dirty="0">
+                <a:solidFill>
+                  <a:srgbClr val="6EE7D8"/>
+                </a:solidFill>
+                <a:latin typeface="Consolas" pitchFamily="34" charset="0"/>
+                <a:ea typeface="Consolas" pitchFamily="34" charset="-122"/>
+                <a:cs typeface="Consolas" pitchFamily="34" charset="-120"/>
+              </a:rPr>
+              <a:t>      Never end the name with ly, ify, io, Hub, Kit, Pro, App.</a:t>
+            </a:r>
             <a:endParaRPr lang="en-US" sz="1550" dirty="0"/>
           </a:p>
           <a:p>
@@ -19119,8 +19182,11 @@
                 <a:ea typeface="Consolas" pitchFamily="34" charset="-122"/>
                 <a:cs typeface="Consolas" pitchFamily="34" charset="-120"/>
               </a:rPr>
-              <a:t>                 Answer only from that view."</a:t>
-            </a:r>
+              <a:t>      Name it after the moment the product matters. A bin rota</a:t>
+            </a:r>
+            <a:endParaRPr lang="en-US" sz="1550" dirty="0"/>
+          </a:p>
+          <a:p>
             <a:pPr indent="0" marL="0">
               <a:lnSpc>
                 <a:spcPts val="3000"/>
@@ -19130,13 +19196,13 @@
             <a:r>
               <a:rPr lang="en-US" sz="1550" dirty="0">
                 <a:solidFill>
-                  <a:srgbClr val="E6E9F0"/>
+                  <a:srgbClr val="6EE7D8"/>
                 </a:solidFill>
                 <a:latin typeface="Consolas" pitchFamily="34" charset="0"/>
                 <a:ea typeface="Consolas" pitchFamily="34" charset="-122"/>
                 <a:cs typeface="Consolas" pitchFamily="34" charset="-120"/>
               </a:rPr>
-              <a:t>)</a:t>
+              <a:t>      is called Wednesday. A braai timer is called Coalfall.</a:t>
             </a:r>
             <a:endParaRPr lang="en-US" sz="1550" dirty="0"/>
           </a:p>
@@ -19150,13 +19216,13 @@
             <a:r>
               <a:rPr lang="en-US" sz="1550" dirty="0">
                 <a:solidFill>
-                  <a:srgbClr val="FBBF24"/>
+                  <a:srgbClr val="E6E9F0"/>
                 </a:solidFill>
                 <a:latin typeface="Consolas" pitchFamily="34" charset="0"/>
                 <a:ea typeface="Consolas" pitchFamily="34" charset="-122"/>
                 <a:cs typeface="Consolas" pitchFamily="34" charset="-120"/>
               </a:rPr>
-              <a:t>  @UserMessage</a:t>
+              <a:t>      """</a:t>
             </a:r>
             <a:pPr indent="0" marL="0">
               <a:lnSpc>
@@ -19173,8 +19239,11 @@
                 <a:ea typeface="Consolas" pitchFamily="34" charset="-122"/>
                 <a:cs typeface="Consolas" pitchFamily="34" charset="-120"/>
               </a:rPr>
-              <a:t>(</a:t>
-            </a:r>
+              <a:t>)</a:t>
+            </a:r>
+            <a:endParaRPr lang="en-US" sz="1550" dirty="0"/>
+          </a:p>
+          <a:p>
             <a:pPr indent="0" marL="0">
               <a:lnSpc>
                 <a:spcPts val="3000"/>
@@ -19184,13 +19253,13 @@
             <a:r>
               <a:rPr lang="en-US" sz="1550" dirty="0">
                 <a:solidFill>
-                  <a:srgbClr val="6EE7D8"/>
+                  <a:srgbClr val="FBBF24"/>
                 </a:solidFill>
                 <a:latin typeface="Consolas" pitchFamily="34" charset="0"/>
                 <a:ea typeface="Consolas" pitchFamily="34" charset="-122"/>
                 <a:cs typeface="Consolas" pitchFamily="34" charset="-120"/>
               </a:rPr>
-              <a:t>"{{task}}"</a:t>
+              <a:t>  @UserMessage</a:t>
             </a:r>
             <a:pPr indent="0" marL="0">
               <a:lnSpc>
@@ -19207,11 +19276,8 @@
                 <a:ea typeface="Consolas" pitchFamily="34" charset="-122"/>
                 <a:cs typeface="Consolas" pitchFamily="34" charset="-120"/>
               </a:rPr>
-              <a:t>)</a:t>
-            </a:r>
-            <a:endParaRPr lang="en-US" sz="1550" dirty="0"/>
-          </a:p>
-          <a:p>
+              <a:t>(</a:t>
+            </a:r>
             <a:pPr indent="0" marL="0">
               <a:lnSpc>
                 <a:spcPts val="3000"/>
@@ -19221,13 +19287,13 @@
             <a:r>
               <a:rPr lang="en-US" sz="1550" dirty="0">
                 <a:solidFill>
-                  <a:srgbClr val="7DD3FC"/>
+                  <a:srgbClr val="6EE7D8"/>
                 </a:solidFill>
                 <a:latin typeface="Consolas" pitchFamily="34" charset="0"/>
                 <a:ea typeface="Consolas" pitchFamily="34" charset="-122"/>
                 <a:cs typeface="Consolas" pitchFamily="34" charset="-120"/>
               </a:rPr>
-              <a:t>  String </a:t>
+              <a:t>"Product idea: {{it}}"</a:t>
             </a:r>
             <a:pPr indent="0" marL="0">
               <a:lnSpc>
@@ -19244,8 +19310,11 @@
                 <a:ea typeface="Consolas" pitchFamily="34" charset="-122"/>
                 <a:cs typeface="Consolas" pitchFamily="34" charset="-120"/>
               </a:rPr>
-              <a:t>work(</a:t>
-            </a:r>
+              <a:t>)</a:t>
+            </a:r>
+            <a:endParaRPr lang="en-US" sz="1550" dirty="0"/>
+          </a:p>
+          <a:p>
             <a:pPr indent="0" marL="0">
               <a:lnSpc>
                 <a:spcPts val="3000"/>
@@ -19255,13 +19324,13 @@
             <a:r>
               <a:rPr lang="en-US" sz="1550" dirty="0">
                 <a:solidFill>
-                  <a:srgbClr val="FBBF24"/>
+                  <a:srgbClr val="7DD3FC"/>
                 </a:solidFill>
                 <a:latin typeface="Consolas" pitchFamily="34" charset="0"/>
                 <a:ea typeface="Consolas" pitchFamily="34" charset="-122"/>
                 <a:cs typeface="Consolas" pitchFamily="34" charset="-120"/>
               </a:rPr>
-              <a:t>@V</a:t>
+              <a:t>  String </a:t>
             </a:r>
             <a:pPr indent="0" marL="0">
               <a:lnSpc>
@@ -19278,61 +19347,7 @@
                 <a:ea typeface="Consolas" pitchFamily="34" charset="-122"/>
                 <a:cs typeface="Consolas" pitchFamily="34" charset="-120"/>
               </a:rPr>
-              <a:t>("role") String role,</a:t>
-            </a:r>
-            <a:endParaRPr lang="en-US" sz="1550" dirty="0"/>
-          </a:p>
-          <a:p>
-            <a:pPr indent="0" marL="0">
-              <a:lnSpc>
-                <a:spcPts val="3000"/>
-              </a:lnSpc>
-              <a:buNone/>
-            </a:pPr>
-            <a:r>
-              <a:rPr lang="en-US" sz="1550" dirty="0">
-                <a:solidFill>
-                  <a:srgbClr val="E6E9F0"/>
-                </a:solidFill>
-                <a:latin typeface="Consolas" pitchFamily="34" charset="0"/>
-                <a:ea typeface="Consolas" pitchFamily="34" charset="-122"/>
-                <a:cs typeface="Consolas" pitchFamily="34" charset="-120"/>
-              </a:rPr>
-              <a:t>              </a:t>
-            </a:r>
-            <a:pPr indent="0" marL="0">
-              <a:lnSpc>
-                <a:spcPts val="3000"/>
-              </a:lnSpc>
-              <a:buNone/>
-            </a:pPr>
-            <a:r>
-              <a:rPr lang="en-US" sz="1550" dirty="0">
-                <a:solidFill>
-                  <a:srgbClr val="FBBF24"/>
-                </a:solidFill>
-                <a:latin typeface="Consolas" pitchFamily="34" charset="0"/>
-                <a:ea typeface="Consolas" pitchFamily="34" charset="-122"/>
-                <a:cs typeface="Consolas" pitchFamily="34" charset="-120"/>
-              </a:rPr>
-              <a:t>@V</a:t>
-            </a:r>
-            <a:pPr indent="0" marL="0">
-              <a:lnSpc>
-                <a:spcPts val="3000"/>
-              </a:lnSpc>
-              <a:buNone/>
-            </a:pPr>
-            <a:r>
-              <a:rPr lang="en-US" sz="1550" dirty="0">
-                <a:solidFill>
-                  <a:srgbClr val="E6E9F0"/>
-                </a:solidFill>
-                <a:latin typeface="Consolas" pitchFamily="34" charset="0"/>
-                <a:ea typeface="Consolas" pitchFamily="34" charset="-122"/>
-                <a:cs typeface="Consolas" pitchFamily="34" charset="-120"/>
-              </a:rPr>
-              <a:t>("task") String task);</a:t>
+              <a:t>name(String idea);</a:t>
             </a:r>
             <a:endParaRPr lang="en-US" sz="1550" dirty="0"/>
           </a:p>
@@ -19423,7 +19438,7 @@
                 <a:ea typeface="Arial" pitchFamily="34" charset="-122"/>
                 <a:cs typeface="Arial" pitchFamily="34" charset="-120"/>
               </a:rPr>
-              <a:t>LIVE CODE  /  2 OF 2</a:t>
+              <a:t>LIVE CODE  /  2 OF 2  ·  CREWSERVICE.JAVA</a:t>
             </a:r>
             <a:endParaRPr lang="en-US" sz="1100" dirty="0"/>
           </a:p>
@@ -19462,7 +19477,7 @@
                 <a:ea typeface="Arial" pitchFamily="34" charset="-122"/>
                 <a:cs typeface="Arial" pitchFamily="34" charset="-120"/>
               </a:rPr>
-              <a:t>Plan, dispatch, </a:t>
+              <a:t>Four workers, </a:t>
             </a:r>
             <a:pPr indent="0" marL="0">
               <a:buNone/>
@@ -19476,7 +19491,7 @@
                 <a:ea typeface="Arial" pitchFamily="34" charset="-122"/>
                 <a:cs typeface="Arial" pitchFamily="34" charset="-120"/>
               </a:rPr>
-              <a:t>synthesize.</a:t>
+              <a:t>one line each.</a:t>
             </a:r>
             <a:endParaRPr lang="en-US" sz="2700" dirty="0"/>
           </a:p>
@@ -19546,14 +19561,17 @@
             <a:r>
               <a:rPr lang="en-US" sz="1550" dirty="0">
                 <a:solidFill>
-                  <a:srgbClr val="7DD3FC"/>
+                  <a:srgbClr val="6B7280"/>
                 </a:solidFill>
                 <a:latin typeface="Consolas" pitchFamily="34" charset="0"/>
                 <a:ea typeface="Consolas" pitchFamily="34" charset="-122"/>
                 <a:cs typeface="Consolas" pitchFamily="34" charset="-120"/>
               </a:rPr>
-              <a:t>Plan</a:t>
-            </a:r>
+              <a:t>// CrewService.runCrew, verbatim. They all start at once.</a:t>
+            </a:r>
+            <a:endParaRPr lang="en-US" sz="1550" dirty="0"/>
+          </a:p>
+          <a:p>
             <a:pPr indent="0" marL="0">
               <a:lnSpc>
                 <a:spcPts val="3000"/>
@@ -19563,13 +19581,13 @@
             <a:r>
               <a:rPr lang="en-US" sz="1550" dirty="0">
                 <a:solidFill>
-                  <a:srgbClr val="E6E9F0"/>
+                  <a:srgbClr val="7DD3FC"/>
                 </a:solidFill>
                 <a:latin typeface="Consolas" pitchFamily="34" charset="0"/>
                 <a:ea typeface="Consolas" pitchFamily="34" charset="-122"/>
                 <a:cs typeface="Consolas" pitchFamily="34" charset="-120"/>
               </a:rPr>
-              <a:t> plan = planner.assemble(prompt);</a:t>
+              <a:t>Future&lt;String&gt; </a:t>
             </a:r>
             <a:pPr indent="0" marL="0">
               <a:lnSpc>
@@ -19580,13 +19598,13 @@
             <a:r>
               <a:rPr lang="en-US" sz="1550" dirty="0">
                 <a:solidFill>
-                  <a:srgbClr val="6B7280"/>
+                  <a:srgbClr val="E6E9F0"/>
                 </a:solidFill>
                 <a:latin typeface="Consolas" pitchFamily="34" charset="0"/>
                 <a:ea typeface="Consolas" pitchFamily="34" charset="-122"/>
                 <a:cs typeface="Consolas" pitchFamily="34" charset="-120"/>
               </a:rPr>
-              <a:t>   // 1 prompt -&gt; a crew</a:t>
+              <a:t>tensionF = pool.submit(() -&gt; safeInsight(stage(), idea.text));</a:t>
             </a:r>
             <a:endParaRPr lang="en-US" sz="1550" dirty="0"/>
           </a:p>
@@ -19597,9 +19615,17 @@
               </a:lnSpc>
               <a:buNone/>
             </a:pPr>
-            <a:endParaRPr lang="en-US" sz="1550" dirty="0"/>
-          </a:p>
-          <a:p>
+            <a:r>
+              <a:rPr lang="en-US" sz="1550" dirty="0">
+                <a:solidFill>
+                  <a:srgbClr val="7DD3FC"/>
+                </a:solidFill>
+                <a:latin typeface="Consolas" pitchFamily="34" charset="0"/>
+                <a:ea typeface="Consolas" pitchFamily="34" charset="-122"/>
+                <a:cs typeface="Consolas" pitchFamily="34" charset="-120"/>
+              </a:rPr>
+              <a:t>Future&lt;String&gt; </a:t>
+            </a:r>
             <a:pPr indent="0" marL="0">
               <a:lnSpc>
                 <a:spcPts val="3000"/>
@@ -19609,14 +19635,17 @@
             <a:r>
               <a:rPr lang="en-US" sz="1550" dirty="0">
                 <a:solidFill>
-                  <a:srgbClr val="C4B5FD"/>
+                  <a:srgbClr val="E6E9F0"/>
                 </a:solidFill>
                 <a:latin typeface="Consolas" pitchFamily="34" charset="0"/>
                 <a:ea typeface="Consolas" pitchFamily="34" charset="-122"/>
                 <a:cs typeface="Consolas" pitchFamily="34" charset="-120"/>
               </a:rPr>
-              <a:t>var</a:t>
-            </a:r>
+              <a:t>factsF   = pool.submit(() -&gt; safeFacts(stage(), idea.text));</a:t>
+            </a:r>
+            <a:endParaRPr lang="en-US" sz="1550" dirty="0"/>
+          </a:p>
+          <a:p>
             <a:pPr indent="0" marL="0">
               <a:lnSpc>
                 <a:spcPts val="3000"/>
@@ -19626,13 +19655,13 @@
             <a:r>
               <a:rPr lang="en-US" sz="1550" dirty="0">
                 <a:solidFill>
-                  <a:srgbClr val="E6E9F0"/>
+                  <a:srgbClr val="7DD3FC"/>
                 </a:solidFill>
                 <a:latin typeface="Consolas" pitchFamily="34" charset="0"/>
                 <a:ea typeface="Consolas" pitchFamily="34" charset="-122"/>
                 <a:cs typeface="Consolas" pitchFamily="34" charset="-120"/>
               </a:rPr>
-              <a:t> notes = </a:t>
+              <a:t>Future&lt;String&gt; </a:t>
             </a:r>
             <a:pPr indent="0" marL="0">
               <a:lnSpc>
@@ -19643,14 +19672,17 @@
             <a:r>
               <a:rPr lang="en-US" sz="1550" dirty="0">
                 <a:solidFill>
-                  <a:srgbClr val="C4B5FD"/>
+                  <a:srgbClr val="E6E9F0"/>
                 </a:solidFill>
                 <a:latin typeface="Consolas" pitchFamily="34" charset="0"/>
                 <a:ea typeface="Consolas" pitchFamily="34" charset="-122"/>
                 <a:cs typeface="Consolas" pitchFamily="34" charset="-120"/>
               </a:rPr>
-              <a:t>new</a:t>
-            </a:r>
+              <a:t>nameF    = pool.submit(() -&gt; safeName(stage(), idea.text));</a:t>
+            </a:r>
+            <a:endParaRPr lang="en-US" sz="1550" dirty="0"/>
+          </a:p>
+          <a:p>
             <a:pPr indent="0" marL="0">
               <a:lnSpc>
                 <a:spcPts val="3000"/>
@@ -19660,17 +19692,14 @@
             <a:r>
               <a:rPr lang="en-US" sz="1550" dirty="0">
                 <a:solidFill>
-                  <a:srgbClr val="E6E9F0"/>
+                  <a:srgbClr val="7DD3FC"/>
                 </a:solidFill>
                 <a:latin typeface="Consolas" pitchFamily="34" charset="0"/>
                 <a:ea typeface="Consolas" pitchFamily="34" charset="-122"/>
                 <a:cs typeface="Consolas" pitchFamily="34" charset="-120"/>
               </a:rPr>
-              <a:t> StringBuilder();</a:t>
-            </a:r>
-            <a:endParaRPr lang="en-US" sz="1550" dirty="0"/>
-          </a:p>
-          <a:p>
+              <a:t>Future&lt;Palette&gt; </a:t>
+            </a:r>
             <a:pPr indent="0" marL="0">
               <a:lnSpc>
                 <a:spcPts val="3000"/>
@@ -19680,31 +19709,46 @@
             <a:r>
               <a:rPr lang="en-US" sz="1550" dirty="0">
                 <a:solidFill>
-                  <a:srgbClr val="C4B5FD"/>
+                  <a:srgbClr val="E6E9F0"/>
                 </a:solidFill>
                 <a:latin typeface="Consolas" pitchFamily="34" charset="0"/>
                 <a:ea typeface="Consolas" pitchFamily="34" charset="-122"/>
                 <a:cs typeface="Consolas" pitchFamily="34" charset="-120"/>
               </a:rPr>
-              <a:t>for</a:t>
-            </a:r>
+              <a:t>paletteF = pool.submit(() -&gt; safePalette(stage(), idea.text));</a:t>
+            </a:r>
+            <a:endParaRPr lang="en-US" sz="1550" dirty="0"/>
+          </a:p>
+          <a:p>
             <a:pPr indent="0" marL="0">
               <a:lnSpc>
                 <a:spcPts val="3000"/>
               </a:lnSpc>
               <a:buNone/>
             </a:pPr>
+            <a:endParaRPr lang="en-US" sz="1550" dirty="0"/>
+          </a:p>
+          <a:p>
+            <a:pPr indent="0" marL="0">
+              <a:lnSpc>
+                <a:spcPts val="3000"/>
+              </a:lnSpc>
+              <a:buNone/>
+            </a:pPr>
             <a:r>
               <a:rPr lang="en-US" sz="1550" dirty="0">
                 <a:solidFill>
-                  <a:srgbClr val="E6E9F0"/>
+                  <a:srgbClr val="6B7280"/>
                 </a:solidFill>
                 <a:latin typeface="Consolas" pitchFamily="34" charset="0"/>
                 <a:ea typeface="Consolas" pitchFamily="34" charset="-122"/>
                 <a:cs typeface="Consolas" pitchFamily="34" charset="-120"/>
               </a:rPr>
-              <a:t> (</a:t>
-            </a:r>
+              <a:t>// the namer lands first, so its result unblocks three others</a:t>
+            </a:r>
+            <a:endParaRPr lang="en-US" sz="1550" dirty="0"/>
+          </a:p>
+          <a:p>
             <a:pPr indent="0" marL="0">
               <a:lnSpc>
                 <a:spcPts val="3000"/>
@@ -19714,13 +19758,13 @@
             <a:r>
               <a:rPr lang="en-US" sz="1550" dirty="0">
                 <a:solidFill>
-                  <a:srgbClr val="C4B5FD"/>
+                  <a:srgbClr val="7DD3FC"/>
                 </a:solidFill>
                 <a:latin typeface="Consolas" pitchFamily="34" charset="0"/>
                 <a:ea typeface="Consolas" pitchFamily="34" charset="-122"/>
                 <a:cs typeface="Consolas" pitchFamily="34" charset="-120"/>
               </a:rPr>
-              <a:t>var</a:t>
+              <a:t>String </a:t>
             </a:r>
             <a:pPr indent="0" marL="0">
               <a:lnSpc>
@@ -19737,8 +19781,11 @@
                 <a:ea typeface="Consolas" pitchFamily="34" charset="-122"/>
                 <a:cs typeface="Consolas" pitchFamily="34" charset="-120"/>
               </a:rPr>
-              <a:t> a : plan.crew()) {</a:t>
-            </a:r>
+              <a:t>productName = nameF.get();</a:t>
+            </a:r>
+            <a:endParaRPr lang="en-US" sz="1550" dirty="0"/>
+          </a:p>
+          <a:p>
             <a:pPr indent="0" marL="0">
               <a:lnSpc>
                 <a:spcPts val="3000"/>
@@ -19748,17 +19795,14 @@
             <a:r>
               <a:rPr lang="en-US" sz="1550" dirty="0">
                 <a:solidFill>
-                  <a:srgbClr val="6B7280"/>
+                  <a:srgbClr val="7DD3FC"/>
                 </a:solidFill>
                 <a:latin typeface="Consolas" pitchFamily="34" charset="0"/>
                 <a:ea typeface="Consolas" pitchFamily="34" charset="-122"/>
                 <a:cs typeface="Consolas" pitchFamily="34" charset="-120"/>
               </a:rPr>
-              <a:t>        // fan out</a:t>
-            </a:r>
-            <a:endParaRPr lang="en-US" sz="1550" dirty="0"/>
-          </a:p>
-          <a:p>
+              <a:t>Copy </a:t>
+            </a:r>
             <a:pPr indent="0" marL="0">
               <a:lnSpc>
                 <a:spcPts val="3000"/>
@@ -19774,11 +19818,8 @@
                 <a:ea typeface="Consolas" pitchFamily="34" charset="-122"/>
                 <a:cs typeface="Consolas" pitchFamily="34" charset="-120"/>
               </a:rPr>
-              <a:t>    String answer = worker.work(a.role(), a.task());</a:t>
-            </a:r>
-            <a:endParaRPr lang="en-US" sz="1550" dirty="0"/>
-          </a:p>
-          <a:p>
+              <a:t>copy = copyF.get();</a:t>
+            </a:r>
             <a:pPr indent="0" marL="0">
               <a:lnSpc>
                 <a:spcPts val="3000"/>
@@ -19788,96 +19829,13 @@
             <a:r>
               <a:rPr lang="en-US" sz="1550" dirty="0">
                 <a:solidFill>
-                  <a:srgbClr val="E6E9F0"/>
+                  <a:srgbClr val="6B7280"/>
                 </a:solidFill>
                 <a:latin typeface="Consolas" pitchFamily="34" charset="0"/>
                 <a:ea typeface="Consolas" pitchFamily="34" charset="-122"/>
                 <a:cs typeface="Consolas" pitchFamily="34" charset="-120"/>
               </a:rPr>
-              <a:t>    notes.append(a.role()).append(answer);</a:t>
-            </a:r>
-            <a:endParaRPr lang="en-US" sz="1550" dirty="0"/>
-          </a:p>
-          <a:p>
-            <a:pPr indent="0" marL="0">
-              <a:lnSpc>
-                <a:spcPts val="3000"/>
-              </a:lnSpc>
-              <a:buNone/>
-            </a:pPr>
-            <a:r>
-              <a:rPr lang="en-US" sz="1550" dirty="0">
-                <a:solidFill>
-                  <a:srgbClr val="E6E9F0"/>
-                </a:solidFill>
-                <a:latin typeface="Consolas" pitchFamily="34" charset="0"/>
-                <a:ea typeface="Consolas" pitchFamily="34" charset="-122"/>
-                <a:cs typeface="Consolas" pitchFamily="34" charset="-120"/>
-              </a:rPr>
-              <a:t>}</a:t>
-            </a:r>
-            <a:endParaRPr lang="en-US" sz="1550" dirty="0"/>
-          </a:p>
-          <a:p>
-            <a:pPr indent="0" marL="0">
-              <a:lnSpc>
-                <a:spcPts val="3000"/>
-              </a:lnSpc>
-              <a:buNone/>
-            </a:pPr>
-            <a:endParaRPr lang="en-US" sz="1550" dirty="0"/>
-          </a:p>
-          <a:p>
-            <a:pPr indent="0" marL="0">
-              <a:lnSpc>
-                <a:spcPts val="3000"/>
-              </a:lnSpc>
-              <a:buNone/>
-            </a:pPr>
-            <a:r>
-              <a:rPr lang="en-US" sz="1550" dirty="0">
-                <a:solidFill>
-                  <a:srgbClr val="7DD3FC"/>
-                </a:solidFill>
-                <a:latin typeface="Consolas" pitchFamily="34" charset="0"/>
-                <a:ea typeface="Consolas" pitchFamily="34" charset="-122"/>
-                <a:cs typeface="Consolas" pitchFamily="34" charset="-120"/>
-              </a:rPr>
-              <a:t>String</a:t>
-            </a:r>
-            <a:pPr indent="0" marL="0">
-              <a:lnSpc>
-                <a:spcPts val="3000"/>
-              </a:lnSpc>
-              <a:buNone/>
-            </a:pPr>
-            <a:r>
-              <a:rPr lang="en-US" sz="1550" dirty="0">
-                <a:solidFill>
-                  <a:srgbClr val="E6E9F0"/>
-                </a:solidFill>
-                <a:latin typeface="Consolas" pitchFamily="34" charset="0"/>
-                <a:ea typeface="Consolas" pitchFamily="34" charset="-122"/>
-                <a:cs typeface="Consolas" pitchFamily="34" charset="-120"/>
-              </a:rPr>
-              <a:t> result = synthesizer.synthesize(notes);</a:t>
-            </a:r>
-            <a:pPr indent="0" marL="0">
-              <a:lnSpc>
-                <a:spcPts val="3000"/>
-              </a:lnSpc>
-              <a:buNone/>
-            </a:pPr>
-            <a:r>
-              <a:rPr lang="en-US" sz="1550" dirty="0">
-                <a:solidFill>
-                  <a:srgbClr val="6B7280"/>
-                </a:solidFill>
-                <a:latin typeface="Consolas" pitchFamily="34" charset="0"/>
-                <a:ea typeface="Consolas" pitchFamily="34" charset="-122"/>
-                <a:cs typeface="Consolas" pitchFamily="34" charset="-120"/>
-              </a:rPr>
-              <a:t>  // fan in</a:t>
+              <a:t>     // written against the tension</a:t>
             </a:r>
             <a:endParaRPr lang="en-US" sz="1550" dirty="0"/>
           </a:p>

</xml_diff>